<commit_message>
SARA deck: full expert-toolchain list from the pulsar training guide
Problem slide goes to a 3x3 chip grid, adding RIPTIDE, PINT, and the
ATNF pulsar catalogue from the system-configuration table on p.8 of
DSES_PulsarGuide_Planning_2026.pdf (dish control omitted - the new
workflow needs it too). Nine chips plus the subdued PSRCHIVE row now
make the old stack's complexity land visually.
</commit_message>
<xml_diff>
--- a/reports/sara-2026/Lowering_the_Barrier_to_Radio_Astronomy_SARA_2026.pptx
+++ b/reports/sara-2026/Lowering_the_Barrier_to_Radio_Astronomy_SARA_2026.pptx
@@ -1131,7 +1131,7 @@
           <a:p>
             <a:r>
               <a:rPr lang="en-US" dirty="0"/>
-              <a:t>Credit where due: this toolchain produces first-rate, professional results, and Rich and Dan built DSES's pulsar program on it. The point is not that the tools are bad — it's that the barrier to entry kept hands-on observing limited to two people. Hundreds of pages of training material is a real number. The grayed row is the kicker: the professional world in common use runs even deeper — PSRCHIVE is a whole additional suite our two experts didn't even need.</a:t>
+              <a:t>Credit where due: this toolchain produces first-rate, professional results, and Rich and Dan built DSES's pulsar program on it. The point is not that the tools are bad — it's that the barrier to entry kept hands-on observing limited to two people. Hundreds of pages of training material is a real number — this tool list is straight from the DSES pulsar training guide's system-configuration table. The grayed row is the kicker: the professional world in common use runs even deeper — PSRCHIVE is a whole additional suite our two experts didn't even need.</a:t>
             </a:r>
             <a:endParaRPr lang="en-US" dirty="0"/>
           </a:p>
@@ -6988,12 +6988,12 @@
         </p:nvSpPr>
         <p:spPr>
           <a:xfrm>
-            <a:off x="566928" y="2212848"/>
-            <a:ext cx="3886200" cy="1024128"/>
+            <a:off x="566928" y="2103120"/>
+            <a:ext cx="2548128" cy="1078992"/>
           </a:xfrm>
           <a:prstGeom prst="roundRect">
             <a:avLst>
-              <a:gd name="adj" fmla="val 7143"/>
+              <a:gd name="adj" fmla="val 6780"/>
             </a:avLst>
           </a:prstGeom>
           <a:solidFill>
@@ -7015,24 +7015,24 @@
         </p:nvSpPr>
         <p:spPr>
           <a:xfrm>
-            <a:off x="768096" y="2322576"/>
-            <a:ext cx="3483864" cy="292608"/>
-          </a:xfrm>
-          <a:prstGeom prst="rect">
-            <a:avLst/>
-          </a:prstGeom>
-          <a:noFill/>
-          <a:ln/>
-        </p:spPr>
-        <p:txBody>
-          <a:bodyPr wrap="square" lIns="0" tIns="0" rIns="0" bIns="0" rtlCol="0" anchor="ctr"/>
-          <a:lstStyle/>
-          <a:p>
-            <a:pPr indent="0" marL="0">
-              <a:buNone/>
-            </a:pPr>
-            <a:r>
-              <a:rPr lang="en-US" sz="1350" b="1" dirty="0">
+            <a:off x="731520" y="2194560"/>
+            <a:ext cx="2218944" cy="274320"/>
+          </a:xfrm>
+          <a:prstGeom prst="rect">
+            <a:avLst/>
+          </a:prstGeom>
+          <a:noFill/>
+          <a:ln/>
+        </p:spPr>
+        <p:txBody>
+          <a:bodyPr wrap="square" lIns="0" tIns="0" rIns="0" bIns="0" rtlCol="0" anchor="ctr"/>
+          <a:lstStyle/>
+          <a:p>
+            <a:pPr indent="0" marL="0">
+              <a:buNone/>
+            </a:pPr>
+            <a:r>
+              <a:rPr lang="en-US" sz="1150" b="1" dirty="0">
                 <a:solidFill>
                   <a:srgbClr val="0A2F40"/>
                 </a:solidFill>
@@ -7042,7 +7042,7 @@
               </a:rPr>
               <a:t>PRESTO v5 + TEMPO1 + TEMPO2</a:t>
             </a:r>
-            <a:endParaRPr lang="en-US" sz="1350" dirty="0"/>
+            <a:endParaRPr lang="en-US" sz="1150" dirty="0"/>
           </a:p>
         </p:txBody>
       </p:sp>
@@ -7054,8 +7054,8 @@
         </p:nvSpPr>
         <p:spPr>
           <a:xfrm>
-            <a:off x="768096" y="2615184"/>
-            <a:ext cx="3483864" cy="566928"/>
+            <a:off x="731520" y="2487168"/>
+            <a:ext cx="2218944" cy="640080"/>
           </a:xfrm>
           <a:prstGeom prst="rect">
             <a:avLst/>
@@ -7071,7 +7071,7 @@
               <a:buNone/>
             </a:pPr>
             <a:r>
-              <a:rPr lang="en-US" sz="1150" dirty="0">
+              <a:rPr lang="en-US" sz="1000" dirty="0">
                 <a:solidFill>
                   <a:srgbClr val="24343C"/>
                 </a:solidFill>
@@ -7079,9 +7079,9 @@
                 <a:ea typeface="Calibri" pitchFamily="34" charset="-122"/>
                 <a:cs typeface="Calibri" pitchFamily="34" charset="-120"/>
               </a:rPr>
-              <a:t>built from source; hand-edited observatory coordinate and clock files</a:t>
-            </a:r>
-            <a:endParaRPr lang="en-US" sz="1150" dirty="0"/>
+              <a:t>built from source; hand-edited observatory and clock files</a:t>
+            </a:r>
+            <a:endParaRPr lang="en-US" sz="1000" dirty="0"/>
           </a:p>
         </p:txBody>
       </p:sp>
@@ -7093,12 +7093,12 @@
         </p:nvSpPr>
         <p:spPr>
           <a:xfrm>
-            <a:off x="4654296" y="2212848"/>
-            <a:ext cx="3886200" cy="1024128"/>
+            <a:off x="3279648" y="2103120"/>
+            <a:ext cx="2548128" cy="1078992"/>
           </a:xfrm>
           <a:prstGeom prst="roundRect">
             <a:avLst>
-              <a:gd name="adj" fmla="val 7143"/>
+              <a:gd name="adj" fmla="val 6780"/>
             </a:avLst>
           </a:prstGeom>
           <a:solidFill>
@@ -7120,24 +7120,24 @@
         </p:nvSpPr>
         <p:spPr>
           <a:xfrm>
-            <a:off x="4855464" y="2322576"/>
-            <a:ext cx="3483864" cy="292608"/>
-          </a:xfrm>
-          <a:prstGeom prst="rect">
-            <a:avLst/>
-          </a:prstGeom>
-          <a:noFill/>
-          <a:ln/>
-        </p:spPr>
-        <p:txBody>
-          <a:bodyPr wrap="square" lIns="0" tIns="0" rIns="0" bIns="0" rtlCol="0" anchor="ctr"/>
-          <a:lstStyle/>
-          <a:p>
-            <a:pPr indent="0" marL="0">
-              <a:buNone/>
-            </a:pPr>
-            <a:r>
-              <a:rPr lang="en-US" sz="1350" b="1" dirty="0">
+            <a:off x="3444240" y="2194560"/>
+            <a:ext cx="2218944" cy="274320"/>
+          </a:xfrm>
+          <a:prstGeom prst="rect">
+            <a:avLst/>
+          </a:prstGeom>
+          <a:noFill/>
+          <a:ln/>
+        </p:spPr>
+        <p:txBody>
+          <a:bodyPr wrap="square" lIns="0" tIns="0" rIns="0" bIns="0" rtlCol="0" anchor="ctr"/>
+          <a:lstStyle/>
+          <a:p>
+            <a:pPr indent="0" marL="0">
+              <a:buNone/>
+            </a:pPr>
+            <a:r>
+              <a:rPr lang="en-US" sz="1150" b="1" dirty="0">
                 <a:solidFill>
                   <a:srgbClr val="0A2F40"/>
                 </a:solidFill>
@@ -7145,9 +7145,9 @@
                 <a:ea typeface="Calibri" pitchFamily="34" charset="-122"/>
                 <a:cs typeface="Calibri" pitchFamily="34" charset="-120"/>
               </a:rPr>
-              <a:t>GNU Radio</a:t>
-            </a:r>
-            <a:endParaRPr lang="en-US" sz="1350" dirty="0"/>
+              <a:t>RIPTIDE</a:t>
+            </a:r>
+            <a:endParaRPr lang="en-US" sz="1150" dirty="0"/>
           </a:p>
         </p:txBody>
       </p:sp>
@@ -7159,8 +7159,8 @@
         </p:nvSpPr>
         <p:spPr>
           <a:xfrm>
-            <a:off x="4855464" y="2615184"/>
-            <a:ext cx="3483864" cy="566928"/>
+            <a:off x="3444240" y="2487168"/>
+            <a:ext cx="2218944" cy="640080"/>
           </a:xfrm>
           <a:prstGeom prst="rect">
             <a:avLst/>
@@ -7176,7 +7176,7 @@
               <a:buNone/>
             </a:pPr>
             <a:r>
-              <a:rPr lang="en-US" sz="1150" dirty="0">
+              <a:rPr lang="en-US" sz="1000" dirty="0">
                 <a:solidFill>
                   <a:srgbClr val="24343C"/>
                 </a:solidFill>
@@ -7184,9 +7184,9 @@
                 <a:ea typeface="Calibri" pitchFamily="34" charset="-122"/>
                 <a:cs typeface="Calibri" pitchFamily="34" charset="-120"/>
               </a:rPr>
-              <a:t>custom filterbank flowgraphs driving the B210</a:t>
-            </a:r>
-            <a:endParaRPr lang="en-US" sz="1150" dirty="0"/>
+              <a:t>a second, independent pulsar-search code (fast-folding)</a:t>
+            </a:r>
+            <a:endParaRPr lang="en-US" sz="1000" dirty="0"/>
           </a:p>
         </p:txBody>
       </p:sp>
@@ -7198,12 +7198,12 @@
         </p:nvSpPr>
         <p:spPr>
           <a:xfrm>
-            <a:off x="566928" y="3392424"/>
-            <a:ext cx="3886200" cy="1024128"/>
+            <a:off x="5992368" y="2103120"/>
+            <a:ext cx="2548128" cy="1078992"/>
           </a:xfrm>
           <a:prstGeom prst="roundRect">
             <a:avLst>
-              <a:gd name="adj" fmla="val 7143"/>
+              <a:gd name="adj" fmla="val 6780"/>
             </a:avLst>
           </a:prstGeom>
           <a:solidFill>
@@ -7225,24 +7225,24 @@
         </p:nvSpPr>
         <p:spPr>
           <a:xfrm>
-            <a:off x="768096" y="3502152"/>
-            <a:ext cx="3483864" cy="292608"/>
-          </a:xfrm>
-          <a:prstGeom prst="rect">
-            <a:avLst/>
-          </a:prstGeom>
-          <a:noFill/>
-          <a:ln/>
-        </p:spPr>
-        <p:txBody>
-          <a:bodyPr wrap="square" lIns="0" tIns="0" rIns="0" bIns="0" rtlCol="0" anchor="ctr"/>
-          <a:lstStyle/>
-          <a:p>
-            <a:pPr indent="0" marL="0">
-              <a:buNone/>
-            </a:pPr>
-            <a:r>
-              <a:rPr lang="en-US" sz="1350" b="1" dirty="0">
+            <a:off x="6156960" y="2194560"/>
+            <a:ext cx="2218944" cy="274320"/>
+          </a:xfrm>
+          <a:prstGeom prst="rect">
+            <a:avLst/>
+          </a:prstGeom>
+          <a:noFill/>
+          <a:ln/>
+        </p:spPr>
+        <p:txBody>
+          <a:bodyPr wrap="square" lIns="0" tIns="0" rIns="0" bIns="0" rtlCol="0" anchor="ctr"/>
+          <a:lstStyle/>
+          <a:p>
+            <a:pPr indent="0" marL="0">
+              <a:buNone/>
+            </a:pPr>
+            <a:r>
+              <a:rPr lang="en-US" sz="1150" b="1" dirty="0">
                 <a:solidFill>
                   <a:srgbClr val="0A2F40"/>
                 </a:solidFill>
@@ -7250,9 +7250,9 @@
                 <a:ea typeface="Calibri" pitchFamily="34" charset="-122"/>
                 <a:cs typeface="Calibri" pitchFamily="34" charset="-120"/>
               </a:rPr>
-              <a:t>SIGPROC</a:t>
-            </a:r>
-            <a:endParaRPr lang="en-US" sz="1350" dirty="0"/>
+              <a:t>GNU Radio</a:t>
+            </a:r>
+            <a:endParaRPr lang="en-US" sz="1150" dirty="0"/>
           </a:p>
         </p:txBody>
       </p:sp>
@@ -7264,8 +7264,8 @@
         </p:nvSpPr>
         <p:spPr>
           <a:xfrm>
-            <a:off x="768096" y="3794760"/>
-            <a:ext cx="3483864" cy="566928"/>
+            <a:off x="6156960" y="2487168"/>
+            <a:ext cx="2218944" cy="640080"/>
           </a:xfrm>
           <a:prstGeom prst="rect">
             <a:avLst/>
@@ -7281,7 +7281,7 @@
               <a:buNone/>
             </a:pPr>
             <a:r>
-              <a:rPr lang="en-US" sz="1150" dirty="0">
+              <a:rPr lang="en-US" sz="1000" dirty="0">
                 <a:solidFill>
                   <a:srgbClr val="24343C"/>
                 </a:solidFill>
@@ -7289,9 +7289,9 @@
                 <a:ea typeface="Calibri" pitchFamily="34" charset="-122"/>
                 <a:cs typeface="Calibri" pitchFamily="34" charset="-120"/>
               </a:rPr>
-              <a:t>filterbank-format utilities</a:t>
-            </a:r>
-            <a:endParaRPr lang="en-US" sz="1150" dirty="0"/>
+              <a:t>custom filterbank flowgraphs driving the B210</a:t>
+            </a:r>
+            <a:endParaRPr lang="en-US" sz="1000" dirty="0"/>
           </a:p>
         </p:txBody>
       </p:sp>
@@ -7303,12 +7303,12 @@
         </p:nvSpPr>
         <p:spPr>
           <a:xfrm>
-            <a:off x="4654296" y="3392424"/>
-            <a:ext cx="3886200" cy="1024128"/>
+            <a:off x="566928" y="3328416"/>
+            <a:ext cx="2548128" cy="1078992"/>
           </a:xfrm>
           <a:prstGeom prst="roundRect">
             <a:avLst>
-              <a:gd name="adj" fmla="val 7143"/>
+              <a:gd name="adj" fmla="val 6780"/>
             </a:avLst>
           </a:prstGeom>
           <a:solidFill>
@@ -7330,24 +7330,24 @@
         </p:nvSpPr>
         <p:spPr>
           <a:xfrm>
-            <a:off x="4855464" y="3502152"/>
-            <a:ext cx="3483864" cy="292608"/>
-          </a:xfrm>
-          <a:prstGeom prst="rect">
-            <a:avLst/>
-          </a:prstGeom>
-          <a:noFill/>
-          <a:ln/>
-        </p:spPr>
-        <p:txBody>
-          <a:bodyPr wrap="square" lIns="0" tIns="0" rIns="0" bIns="0" rtlCol="0" anchor="ctr"/>
-          <a:lstStyle/>
-          <a:p>
-            <a:pPr indent="0" marL="0">
-              <a:buNone/>
-            </a:pPr>
-            <a:r>
-              <a:rPr lang="en-US" sz="1350" b="1" dirty="0">
+            <a:off x="731520" y="3419856"/>
+            <a:ext cx="2218944" cy="274320"/>
+          </a:xfrm>
+          <a:prstGeom prst="rect">
+            <a:avLst/>
+          </a:prstGeom>
+          <a:noFill/>
+          <a:ln/>
+        </p:spPr>
+        <p:txBody>
+          <a:bodyPr wrap="square" lIns="0" tIns="0" rIns="0" bIns="0" rtlCol="0" anchor="ctr"/>
+          <a:lstStyle/>
+          <a:p>
+            <a:pPr indent="0" marL="0">
+              <a:buNone/>
+            </a:pPr>
+            <a:r>
+              <a:rPr lang="en-US" sz="1150" b="1" dirty="0">
                 <a:solidFill>
                   <a:srgbClr val="0A2F40"/>
                 </a:solidFill>
@@ -7355,9 +7355,9 @@
                 <a:ea typeface="Calibri" pitchFamily="34" charset="-122"/>
                 <a:cs typeface="Calibri" pitchFamily="34" charset="-120"/>
               </a:rPr>
-              <a:t>blimpy / watutil</a:t>
-            </a:r>
-            <a:endParaRPr lang="en-US" sz="1350" dirty="0"/>
+              <a:t>SIGPROC</a:t>
+            </a:r>
+            <a:endParaRPr lang="en-US" sz="1150" dirty="0"/>
           </a:p>
         </p:txBody>
       </p:sp>
@@ -7369,8 +7369,8 @@
         </p:nvSpPr>
         <p:spPr>
           <a:xfrm>
-            <a:off x="4855464" y="3794760"/>
-            <a:ext cx="3483864" cy="566928"/>
+            <a:off x="731520" y="3712464"/>
+            <a:ext cx="2218944" cy="640080"/>
           </a:xfrm>
           <a:prstGeom prst="rect">
             <a:avLst/>
@@ -7386,7 +7386,7 @@
               <a:buNone/>
             </a:pPr>
             <a:r>
-              <a:rPr lang="en-US" sz="1150" dirty="0">
+              <a:rPr lang="en-US" sz="1000" dirty="0">
                 <a:solidFill>
                   <a:srgbClr val="24343C"/>
                 </a:solidFill>
@@ -7394,9 +7394,9 @@
                 <a:ea typeface="Calibri" pitchFamily="34" charset="-122"/>
                 <a:cs typeface="Calibri" pitchFamily="34" charset="-120"/>
               </a:rPr>
-              <a:t>Breakthrough Listen tools for RFI and saturation checks</a:t>
-            </a:r>
-            <a:endParaRPr lang="en-US" sz="1150" dirty="0"/>
+              <a:t>filterbank-format utilities</a:t>
+            </a:r>
+            <a:endParaRPr lang="en-US" sz="1000" dirty="0"/>
           </a:p>
         </p:txBody>
       </p:sp>
@@ -7408,12 +7408,12 @@
         </p:nvSpPr>
         <p:spPr>
           <a:xfrm>
-            <a:off x="566928" y="4572000"/>
-            <a:ext cx="3886200" cy="1024128"/>
+            <a:off x="3279648" y="3328416"/>
+            <a:ext cx="2548128" cy="1078992"/>
           </a:xfrm>
           <a:prstGeom prst="roundRect">
             <a:avLst>
-              <a:gd name="adj" fmla="val 7143"/>
+              <a:gd name="adj" fmla="val 6780"/>
             </a:avLst>
           </a:prstGeom>
           <a:solidFill>
@@ -7435,24 +7435,24 @@
         </p:nvSpPr>
         <p:spPr>
           <a:xfrm>
-            <a:off x="768096" y="4681728"/>
-            <a:ext cx="3483864" cy="292608"/>
-          </a:xfrm>
-          <a:prstGeom prst="rect">
-            <a:avLst/>
-          </a:prstGeom>
-          <a:noFill/>
-          <a:ln/>
-        </p:spPr>
-        <p:txBody>
-          <a:bodyPr wrap="square" lIns="0" tIns="0" rIns="0" bIns="0" rtlCol="0" anchor="ctr"/>
-          <a:lstStyle/>
-          <a:p>
-            <a:pPr indent="0" marL="0">
-              <a:buNone/>
-            </a:pPr>
-            <a:r>
-              <a:rPr lang="en-US" sz="1350" b="1" dirty="0">
+            <a:off x="3444240" y="3419856"/>
+            <a:ext cx="2218944" cy="274320"/>
+          </a:xfrm>
+          <a:prstGeom prst="rect">
+            <a:avLst/>
+          </a:prstGeom>
+          <a:noFill/>
+          <a:ln/>
+        </p:spPr>
+        <p:txBody>
+          <a:bodyPr wrap="square" lIns="0" tIns="0" rIns="0" bIns="0" rtlCol="0" anchor="ctr"/>
+          <a:lstStyle/>
+          <a:p>
+            <a:pPr indent="0" marL="0">
+              <a:buNone/>
+            </a:pPr>
+            <a:r>
+              <a:rPr lang="en-US" sz="1150" b="1" dirty="0">
                 <a:solidFill>
                   <a:srgbClr val="0A2F40"/>
                 </a:solidFill>
@@ -7460,9 +7460,9 @@
                 <a:ea typeface="Calibri" pitchFamily="34" charset="-122"/>
                 <a:cs typeface="Calibri" pitchFamily="34" charset="-120"/>
               </a:rPr>
-              <a:t>Murmur + Best Profile Analyzer</a:t>
-            </a:r>
-            <a:endParaRPr lang="en-US" sz="1350" dirty="0"/>
+              <a:t>blimpy / watutil</a:t>
+            </a:r>
+            <a:endParaRPr lang="en-US" sz="1150" dirty="0"/>
           </a:p>
         </p:txBody>
       </p:sp>
@@ -7474,8 +7474,8 @@
         </p:nvSpPr>
         <p:spPr>
           <a:xfrm>
-            <a:off x="768096" y="4974336"/>
-            <a:ext cx="3483864" cy="566928"/>
+            <a:off x="3444240" y="3712464"/>
+            <a:ext cx="2218944" cy="640080"/>
           </a:xfrm>
           <a:prstGeom prst="rect">
             <a:avLst/>
@@ -7491,7 +7491,7 @@
               <a:buNone/>
             </a:pPr>
             <a:r>
-              <a:rPr lang="en-US" sz="1150" dirty="0">
+              <a:rPr lang="en-US" sz="1000" dirty="0">
                 <a:solidFill>
                   <a:srgbClr val="24343C"/>
                 </a:solidFill>
@@ -7499,9 +7499,9 @@
                 <a:ea typeface="Calibri" pitchFamily="34" charset="-122"/>
                 <a:cs typeface="Calibri" pitchFamily="34" charset="-120"/>
               </a:rPr>
-              <a:t>I0NAA planning and analysis tools — run under Wine</a:t>
-            </a:r>
-            <a:endParaRPr lang="en-US" sz="1150" dirty="0"/>
+              <a:t>Breakthrough Listen RFI and saturation checks</a:t>
+            </a:r>
+            <a:endParaRPr lang="en-US" sz="1000" dirty="0"/>
           </a:p>
         </p:txBody>
       </p:sp>
@@ -7513,12 +7513,12 @@
         </p:nvSpPr>
         <p:spPr>
           <a:xfrm>
-            <a:off x="4654296" y="4572000"/>
-            <a:ext cx="3886200" cy="1024128"/>
+            <a:off x="5992368" y="3328416"/>
+            <a:ext cx="2548128" cy="1078992"/>
           </a:xfrm>
           <a:prstGeom prst="roundRect">
             <a:avLst>
-              <a:gd name="adj" fmla="val 7143"/>
+              <a:gd name="adj" fmla="val 6780"/>
             </a:avLst>
           </a:prstGeom>
           <a:solidFill>
@@ -7540,24 +7540,24 @@
         </p:nvSpPr>
         <p:spPr>
           <a:xfrm>
-            <a:off x="4855464" y="4681728"/>
-            <a:ext cx="3483864" cy="292608"/>
-          </a:xfrm>
-          <a:prstGeom prst="rect">
-            <a:avLst/>
-          </a:prstGeom>
-          <a:noFill/>
-          <a:ln/>
-        </p:spPr>
-        <p:txBody>
-          <a:bodyPr wrap="square" lIns="0" tIns="0" rIns="0" bIns="0" rtlCol="0" anchor="ctr"/>
-          <a:lstStyle/>
-          <a:p>
-            <a:pPr indent="0" marL="0">
-              <a:buNone/>
-            </a:pPr>
-            <a:r>
-              <a:rPr lang="en-US" sz="1350" b="1" dirty="0">
+            <a:off x="6156960" y="3419856"/>
+            <a:ext cx="2218944" cy="274320"/>
+          </a:xfrm>
+          <a:prstGeom prst="rect">
+            <a:avLst/>
+          </a:prstGeom>
+          <a:noFill/>
+          <a:ln/>
+        </p:spPr>
+        <p:txBody>
+          <a:bodyPr wrap="square" lIns="0" tIns="0" rIns="0" bIns="0" rtlCol="0" anchor="ctr"/>
+          <a:lstStyle/>
+          <a:p>
+            <a:pPr indent="0" marL="0">
+              <a:buNone/>
+            </a:pPr>
+            <a:r>
+              <a:rPr lang="en-US" sz="1150" b="1" dirty="0">
                 <a:solidFill>
                   <a:srgbClr val="0A2F40"/>
                 </a:solidFill>
@@ -7565,9 +7565,9 @@
                 <a:ea typeface="Calibri" pitchFamily="34" charset="-122"/>
                 <a:cs typeface="Calibri" pitchFamily="34" charset="-120"/>
               </a:rPr>
-              <a:t>Stellarium + experience</a:t>
-            </a:r>
-            <a:endParaRPr lang="en-US" sz="1350" dirty="0"/>
+              <a:t>PINT</a:t>
+            </a:r>
+            <a:endParaRPr lang="en-US" sz="1150" dirty="0"/>
           </a:p>
         </p:txBody>
       </p:sp>
@@ -7579,8 +7579,8 @@
         </p:nvSpPr>
         <p:spPr>
           <a:xfrm>
-            <a:off x="4855464" y="4974336"/>
-            <a:ext cx="3483864" cy="566928"/>
+            <a:off x="6156960" y="3712464"/>
+            <a:ext cx="2218944" cy="640080"/>
           </a:xfrm>
           <a:prstGeom prst="rect">
             <a:avLst/>
@@ -7596,7 +7596,7 @@
               <a:buNone/>
             </a:pPr>
             <a:r>
-              <a:rPr lang="en-US" sz="1150" dirty="0">
+              <a:rPr lang="en-US" sz="1000" dirty="0">
                 <a:solidFill>
                   <a:srgbClr val="24343C"/>
                 </a:solidFill>
@@ -7604,9 +7604,9 @@
                 <a:ea typeface="Calibri" pitchFamily="34" charset="-122"/>
                 <a:cs typeface="Calibri" pitchFamily="34" charset="-120"/>
               </a:rPr>
-              <a:t>above all, knowing how the pieces fit together</a:t>
-            </a:r>
-            <a:endParaRPr lang="en-US" sz="1150" dirty="0"/>
+              <a:t>high-precision pulsar timing in Python</a:t>
+            </a:r>
+            <a:endParaRPr lang="en-US" sz="1000" dirty="0"/>
           </a:p>
         </p:txBody>
       </p:sp>
@@ -7618,12 +7618,327 @@
         </p:nvSpPr>
         <p:spPr>
           <a:xfrm>
-            <a:off x="566928" y="5760720"/>
-            <a:ext cx="7973568" cy="566928"/>
+            <a:off x="566928" y="4553712"/>
+            <a:ext cx="2548128" cy="1078992"/>
           </a:xfrm>
           <a:prstGeom prst="roundRect">
             <a:avLst>
-              <a:gd name="adj" fmla="val 12903"/>
+              <a:gd name="adj" fmla="val 6780"/>
+            </a:avLst>
+          </a:prstGeom>
+          <a:solidFill>
+            <a:srgbClr val="EFF4F7"/>
+          </a:solidFill>
+          <a:ln w="9525">
+            <a:solidFill>
+              <a:srgbClr val="D7E3EA"/>
+            </a:solidFill>
+            <a:prstDash val="solid"/>
+          </a:ln>
+        </p:spPr>
+      </p:sp>
+      <p:sp>
+        <p:nvSpPr>
+          <p:cNvPr id="27" name="Text 24"/>
+          <p:cNvSpPr/>
+          <p:nvPr/>
+        </p:nvSpPr>
+        <p:spPr>
+          <a:xfrm>
+            <a:off x="731520" y="4645152"/>
+            <a:ext cx="2218944" cy="274320"/>
+          </a:xfrm>
+          <a:prstGeom prst="rect">
+            <a:avLst/>
+          </a:prstGeom>
+          <a:noFill/>
+          <a:ln/>
+        </p:spPr>
+        <p:txBody>
+          <a:bodyPr wrap="square" lIns="0" tIns="0" rIns="0" bIns="0" rtlCol="0" anchor="ctr"/>
+          <a:lstStyle/>
+          <a:p>
+            <a:pPr indent="0" marL="0">
+              <a:buNone/>
+            </a:pPr>
+            <a:r>
+              <a:rPr lang="en-US" sz="1150" b="1" dirty="0">
+                <a:solidFill>
+                  <a:srgbClr val="0A2F40"/>
+                </a:solidFill>
+                <a:latin typeface="Calibri" pitchFamily="34" charset="0"/>
+                <a:ea typeface="Calibri" pitchFamily="34" charset="-122"/>
+                <a:cs typeface="Calibri" pitchFamily="34" charset="-120"/>
+              </a:rPr>
+              <a:t>ATNF pulsar catalogue</a:t>
+            </a:r>
+            <a:endParaRPr lang="en-US" sz="1150" dirty="0"/>
+          </a:p>
+        </p:txBody>
+      </p:sp>
+      <p:sp>
+        <p:nvSpPr>
+          <p:cNvPr id="28" name="Text 25"/>
+          <p:cNvSpPr/>
+          <p:nvPr/>
+        </p:nvSpPr>
+        <p:spPr>
+          <a:xfrm>
+            <a:off x="731520" y="4937760"/>
+            <a:ext cx="2218944" cy="640080"/>
+          </a:xfrm>
+          <a:prstGeom prst="rect">
+            <a:avLst/>
+          </a:prstGeom>
+          <a:noFill/>
+          <a:ln/>
+        </p:spPr>
+        <p:txBody>
+          <a:bodyPr wrap="square" lIns="0" tIns="0" rIns="0" bIns="0" rtlCol="0" anchor="t"/>
+          <a:lstStyle/>
+          <a:p>
+            <a:pPr indent="0" marL="0">
+              <a:buNone/>
+            </a:pPr>
+            <a:r>
+              <a:rPr lang="en-US" sz="1000" dirty="0">
+                <a:solidFill>
+                  <a:srgbClr val="24343C"/>
+                </a:solidFill>
+                <a:latin typeface="Calibri" pitchFamily="34" charset="0"/>
+                <a:ea typeface="Calibri" pitchFamily="34" charset="-122"/>
+                <a:cs typeface="Calibri" pitchFamily="34" charset="-120"/>
+              </a:rPr>
+              <a:t>ephemeris data (.par) for every fold</a:t>
+            </a:r>
+            <a:endParaRPr lang="en-US" sz="1000" dirty="0"/>
+          </a:p>
+        </p:txBody>
+      </p:sp>
+      <p:sp>
+        <p:nvSpPr>
+          <p:cNvPr id="29" name="Shape 26"/>
+          <p:cNvSpPr/>
+          <p:nvPr/>
+        </p:nvSpPr>
+        <p:spPr>
+          <a:xfrm>
+            <a:off x="3279648" y="4553712"/>
+            <a:ext cx="2548128" cy="1078992"/>
+          </a:xfrm>
+          <a:prstGeom prst="roundRect">
+            <a:avLst>
+              <a:gd name="adj" fmla="val 6780"/>
+            </a:avLst>
+          </a:prstGeom>
+          <a:solidFill>
+            <a:srgbClr val="EFF4F7"/>
+          </a:solidFill>
+          <a:ln w="9525">
+            <a:solidFill>
+              <a:srgbClr val="D7E3EA"/>
+            </a:solidFill>
+            <a:prstDash val="solid"/>
+          </a:ln>
+        </p:spPr>
+      </p:sp>
+      <p:sp>
+        <p:nvSpPr>
+          <p:cNvPr id="30" name="Text 27"/>
+          <p:cNvSpPr/>
+          <p:nvPr/>
+        </p:nvSpPr>
+        <p:spPr>
+          <a:xfrm>
+            <a:off x="3444240" y="4645152"/>
+            <a:ext cx="2218944" cy="274320"/>
+          </a:xfrm>
+          <a:prstGeom prst="rect">
+            <a:avLst/>
+          </a:prstGeom>
+          <a:noFill/>
+          <a:ln/>
+        </p:spPr>
+        <p:txBody>
+          <a:bodyPr wrap="square" lIns="0" tIns="0" rIns="0" bIns="0" rtlCol="0" anchor="ctr"/>
+          <a:lstStyle/>
+          <a:p>
+            <a:pPr indent="0" marL="0">
+              <a:buNone/>
+            </a:pPr>
+            <a:r>
+              <a:rPr lang="en-US" sz="1150" b="1" dirty="0">
+                <a:solidFill>
+                  <a:srgbClr val="0A2F40"/>
+                </a:solidFill>
+                <a:latin typeface="Calibri" pitchFamily="34" charset="0"/>
+                <a:ea typeface="Calibri" pitchFamily="34" charset="-122"/>
+                <a:cs typeface="Calibri" pitchFamily="34" charset="-120"/>
+              </a:rPr>
+              <a:t>Murmur + Best Profile Analyzer</a:t>
+            </a:r>
+            <a:endParaRPr lang="en-US" sz="1150" dirty="0"/>
+          </a:p>
+        </p:txBody>
+      </p:sp>
+      <p:sp>
+        <p:nvSpPr>
+          <p:cNvPr id="31" name="Text 28"/>
+          <p:cNvSpPr/>
+          <p:nvPr/>
+        </p:nvSpPr>
+        <p:spPr>
+          <a:xfrm>
+            <a:off x="3444240" y="4937760"/>
+            <a:ext cx="2218944" cy="640080"/>
+          </a:xfrm>
+          <a:prstGeom prst="rect">
+            <a:avLst/>
+          </a:prstGeom>
+          <a:noFill/>
+          <a:ln/>
+        </p:spPr>
+        <p:txBody>
+          <a:bodyPr wrap="square" lIns="0" tIns="0" rIns="0" bIns="0" rtlCol="0" anchor="t"/>
+          <a:lstStyle/>
+          <a:p>
+            <a:pPr indent="0" marL="0">
+              <a:buNone/>
+            </a:pPr>
+            <a:r>
+              <a:rPr lang="en-US" sz="1000" dirty="0">
+                <a:solidFill>
+                  <a:srgbClr val="24343C"/>
+                </a:solidFill>
+                <a:latin typeface="Calibri" pitchFamily="34" charset="0"/>
+                <a:ea typeface="Calibri" pitchFamily="34" charset="-122"/>
+                <a:cs typeface="Calibri" pitchFamily="34" charset="-120"/>
+              </a:rPr>
+              <a:t>I0NAA planning/analysis tools — run under Wine</a:t>
+            </a:r>
+            <a:endParaRPr lang="en-US" sz="1000" dirty="0"/>
+          </a:p>
+        </p:txBody>
+      </p:sp>
+      <p:sp>
+        <p:nvSpPr>
+          <p:cNvPr id="32" name="Shape 29"/>
+          <p:cNvSpPr/>
+          <p:nvPr/>
+        </p:nvSpPr>
+        <p:spPr>
+          <a:xfrm>
+            <a:off x="5992368" y="4553712"/>
+            <a:ext cx="2548128" cy="1078992"/>
+          </a:xfrm>
+          <a:prstGeom prst="roundRect">
+            <a:avLst>
+              <a:gd name="adj" fmla="val 6780"/>
+            </a:avLst>
+          </a:prstGeom>
+          <a:solidFill>
+            <a:srgbClr val="EFF4F7"/>
+          </a:solidFill>
+          <a:ln w="9525">
+            <a:solidFill>
+              <a:srgbClr val="D7E3EA"/>
+            </a:solidFill>
+            <a:prstDash val="solid"/>
+          </a:ln>
+        </p:spPr>
+      </p:sp>
+      <p:sp>
+        <p:nvSpPr>
+          <p:cNvPr id="33" name="Text 30"/>
+          <p:cNvSpPr/>
+          <p:nvPr/>
+        </p:nvSpPr>
+        <p:spPr>
+          <a:xfrm>
+            <a:off x="6156960" y="4645152"/>
+            <a:ext cx="2218944" cy="274320"/>
+          </a:xfrm>
+          <a:prstGeom prst="rect">
+            <a:avLst/>
+          </a:prstGeom>
+          <a:noFill/>
+          <a:ln/>
+        </p:spPr>
+        <p:txBody>
+          <a:bodyPr wrap="square" lIns="0" tIns="0" rIns="0" bIns="0" rtlCol="0" anchor="ctr"/>
+          <a:lstStyle/>
+          <a:p>
+            <a:pPr indent="0" marL="0">
+              <a:buNone/>
+            </a:pPr>
+            <a:r>
+              <a:rPr lang="en-US" sz="1150" b="1" dirty="0">
+                <a:solidFill>
+                  <a:srgbClr val="0A2F40"/>
+                </a:solidFill>
+                <a:latin typeface="Calibri" pitchFamily="34" charset="0"/>
+                <a:ea typeface="Calibri" pitchFamily="34" charset="-122"/>
+                <a:cs typeface="Calibri" pitchFamily="34" charset="-120"/>
+              </a:rPr>
+              <a:t>Stellarium + experience</a:t>
+            </a:r>
+            <a:endParaRPr lang="en-US" sz="1150" dirty="0"/>
+          </a:p>
+        </p:txBody>
+      </p:sp>
+      <p:sp>
+        <p:nvSpPr>
+          <p:cNvPr id="34" name="Text 31"/>
+          <p:cNvSpPr/>
+          <p:nvPr/>
+        </p:nvSpPr>
+        <p:spPr>
+          <a:xfrm>
+            <a:off x="6156960" y="4937760"/>
+            <a:ext cx="2218944" cy="640080"/>
+          </a:xfrm>
+          <a:prstGeom prst="rect">
+            <a:avLst/>
+          </a:prstGeom>
+          <a:noFill/>
+          <a:ln/>
+        </p:spPr>
+        <p:txBody>
+          <a:bodyPr wrap="square" lIns="0" tIns="0" rIns="0" bIns="0" rtlCol="0" anchor="t"/>
+          <a:lstStyle/>
+          <a:p>
+            <a:pPr indent="0" marL="0">
+              <a:buNone/>
+            </a:pPr>
+            <a:r>
+              <a:rPr lang="en-US" sz="1000" dirty="0">
+                <a:solidFill>
+                  <a:srgbClr val="24343C"/>
+                </a:solidFill>
+                <a:latin typeface="Calibri" pitchFamily="34" charset="0"/>
+                <a:ea typeface="Calibri" pitchFamily="34" charset="-122"/>
+                <a:cs typeface="Calibri" pitchFamily="34" charset="-120"/>
+              </a:rPr>
+              <a:t>above all, knowing how the pieces fit together</a:t>
+            </a:r>
+            <a:endParaRPr lang="en-US" sz="1000" dirty="0"/>
+          </a:p>
+        </p:txBody>
+      </p:sp>
+      <p:sp>
+        <p:nvSpPr>
+          <p:cNvPr id="35" name="Shape 32"/>
+          <p:cNvSpPr/>
+          <p:nvPr/>
+        </p:nvSpPr>
+        <p:spPr>
+          <a:xfrm>
+            <a:off x="566928" y="5815584"/>
+            <a:ext cx="7973568" cy="512064"/>
+          </a:xfrm>
+          <a:prstGeom prst="roundRect">
+            <a:avLst>
+              <a:gd name="adj" fmla="val 14286"/>
             </a:avLst>
           </a:prstGeom>
           <a:solidFill>
@@ -7639,30 +7954,30 @@
       </p:sp>
       <p:sp>
         <p:nvSpPr>
-          <p:cNvPr id="27" name="Text 24"/>
-          <p:cNvSpPr/>
-          <p:nvPr/>
-        </p:nvSpPr>
-        <p:spPr>
-          <a:xfrm>
-            <a:off x="768096" y="5760720"/>
-            <a:ext cx="7571232" cy="566928"/>
-          </a:xfrm>
-          <a:prstGeom prst="rect">
-            <a:avLst/>
-          </a:prstGeom>
-          <a:noFill/>
-          <a:ln/>
-        </p:spPr>
-        <p:txBody>
-          <a:bodyPr wrap="square" lIns="0" tIns="0" rIns="0" bIns="0" rtlCol="0" anchor="ctr"/>
-          <a:lstStyle/>
-          <a:p>
-            <a:pPr indent="0" marL="0">
-              <a:buNone/>
-            </a:pPr>
-            <a:r>
-              <a:rPr lang="en-US" sz="1150" b="1" dirty="0">
+          <p:cNvPr id="36" name="Text 33"/>
+          <p:cNvSpPr/>
+          <p:nvPr/>
+        </p:nvSpPr>
+        <p:spPr>
+          <a:xfrm>
+            <a:off x="768096" y="5815584"/>
+            <a:ext cx="7571232" cy="512064"/>
+          </a:xfrm>
+          <a:prstGeom prst="rect">
+            <a:avLst/>
+          </a:prstGeom>
+          <a:noFill/>
+          <a:ln/>
+        </p:spPr>
+        <p:txBody>
+          <a:bodyPr wrap="square" lIns="0" tIns="0" rIns="0" bIns="0" rtlCol="0" anchor="ctr"/>
+          <a:lstStyle/>
+          <a:p>
+            <a:pPr indent="0" marL="0">
+              <a:buNone/>
+            </a:pPr>
+            <a:r>
+              <a:rPr lang="en-US" sz="1100" b="1" dirty="0">
                 <a:solidFill>
                   <a:srgbClr val="6B7A82"/>
                 </a:solidFill>
@@ -7676,7 +7991,7 @@
               <a:buNone/>
             </a:pPr>
             <a:r>
-              <a:rPr lang="en-US" sz="1150" dirty="0">
+              <a:rPr lang="en-US" sz="1100" dirty="0">
                 <a:solidFill>
                   <a:srgbClr val="93A2AA"/>
                 </a:solidFill>
@@ -7686,13 +8001,13 @@
               </a:rPr>
               <a:t>  —  the professional community’s archiving &amp; timing suite, in common use — beyond even our experts’ stack</a:t>
             </a:r>
-            <a:endParaRPr lang="en-US" sz="1150" dirty="0"/>
-          </a:p>
-        </p:txBody>
-      </p:sp>
-      <p:sp>
-        <p:nvSpPr>
-          <p:cNvPr id="28" name="Shape 25"/>
+            <a:endParaRPr lang="en-US" sz="1100" dirty="0"/>
+          </a:p>
+        </p:txBody>
+      </p:sp>
+      <p:sp>
+        <p:nvSpPr>
+          <p:cNvPr id="37" name="Shape 34"/>
           <p:cNvSpPr/>
           <p:nvPr/>
         </p:nvSpPr>
@@ -7719,7 +8034,7 @@
       </p:sp>
       <p:sp>
         <p:nvSpPr>
-          <p:cNvPr id="29" name="Text 26"/>
+          <p:cNvPr id="38" name="Text 35"/>
           <p:cNvSpPr/>
           <p:nvPr/>
         </p:nvSpPr>
@@ -7758,7 +8073,7 @@
       </p:sp>
       <p:sp>
         <p:nvSpPr>
-          <p:cNvPr id="30" name="Text 27"/>
+          <p:cNvPr id="39" name="Text 36"/>
           <p:cNvSpPr/>
           <p:nvPr/>
         </p:nvSpPr>
@@ -7797,7 +8112,7 @@
       </p:sp>
       <p:sp>
         <p:nvSpPr>
-          <p:cNvPr id="31" name="Shape 28"/>
+          <p:cNvPr id="40" name="Shape 37"/>
           <p:cNvSpPr/>
           <p:nvPr/>
         </p:nvSpPr>
@@ -7824,7 +8139,7 @@
       </p:sp>
       <p:sp>
         <p:nvSpPr>
-          <p:cNvPr id="32" name="Text 29"/>
+          <p:cNvPr id="41" name="Text 38"/>
           <p:cNvSpPr/>
           <p:nvPr/>
         </p:nvSpPr>
@@ -7863,7 +8178,7 @@
       </p:sp>
       <p:sp>
         <p:nvSpPr>
-          <p:cNvPr id="33" name="Text 30"/>
+          <p:cNvPr id="42" name="Text 39"/>
           <p:cNvSpPr/>
           <p:nvPr/>
         </p:nvSpPr>
@@ -7902,7 +8217,7 @@
       </p:sp>
       <p:sp>
         <p:nvSpPr>
-          <p:cNvPr id="34" name="Text 31"/>
+          <p:cNvPr id="43" name="Text 40"/>
           <p:cNvSpPr/>
           <p:nvPr/>
         </p:nvSpPr>

</xml_diff>

<commit_message>
SARA deck: make PowerPoint's native slide numbers work
Root cause of "Insert Slide Number does nothing": the pptxgenjs-built
master and layout carry no sldNum placeholder, and PowerPoint's
Header & Footer feature only reveals an inherited placeholder - it
never creates one. Surgical XML fix in Rick's master file (string
insertion before </p:spTree>, everything else byte-identical):
- slideMaster1/slideLayout1: inheritable right-aligned 8.5pt gray
  sldNum placeholder at the old manual-number position, so the
  native dialog works from now on
- slides 2-16: instantiated slidenum FIELDS (auto-renumber on
  insert/reorder); dark title/closing slides left unnumbered
Validated + verified rendering via PowerPoint export.
</commit_message>
<xml_diff>
--- a/reports/sara-2026/Lowering_the_Barrier_to_Radio_Astronomy_SARA_2026.pptx
+++ b/reports/sara-2026/Lowering_the_Barrier_to_Radio_Astronomy_SARA_2026.pptx
@@ -1778,6 +1778,52 @@
           <a:chExt cx="0" cy="0"/>
         </a:xfrm>
       </p:grpSpPr>
+      <p:sp>
+        <p:nvSpPr>
+          <p:cNvPr id="2" name="Slide Number Placeholder 2"/>
+          <p:cNvSpPr>
+            <a:spLocks noGrp="1"/>
+          </p:cNvSpPr>
+          <p:nvPr>
+            <p:ph type="sldNum" sz="quarter" idx="4"/>
+          </p:nvPr>
+        </p:nvSpPr>
+        <p:spPr>
+          <a:xfrm>
+            <a:off x="11477880" y="6473952"/>
+            <a:ext cx="457200" cy="228600"/>
+          </a:xfrm>
+          <a:prstGeom prst="rect">
+            <a:avLst/>
+          </a:prstGeom>
+        </p:spPr>
+        <p:txBody>
+          <a:bodyPr vert="horz" lIns="0" tIns="0" rIns="0" bIns="0" rtlCol="0" anchor="ctr"/>
+          <a:lstStyle>
+            <a:lvl1pPr algn="r">
+              <a:defRPr sz="850">
+                <a:solidFill>
+                  <a:srgbClr val="6B7A82"/>
+                </a:solidFill>
+                <a:latin typeface="Calibri"/>
+              </a:defRPr>
+            </a:lvl1pPr>
+          </a:lstStyle>
+          <a:p>
+            <a:pPr algn="r"/>
+            <a:fld id="{51DC1C96-102D-4764-8BE2-750FA6264AFB}" type="slidenum">
+              <a:rPr lang="en-US" sz="850" dirty="0">
+                <a:solidFill>
+                  <a:srgbClr val="6B7A82"/>
+                </a:solidFill>
+                <a:latin typeface="Calibri"/>
+              </a:rPr>
+              <a:t>‹#›</a:t>
+            </a:fld>
+            <a:endParaRPr lang="en-US" sz="850" dirty="0"/>
+          </a:p>
+        </p:txBody>
+      </p:sp>
     </p:spTree>
   </p:cSld>
   <p:clrMapOvr>
@@ -1808,6 +1854,52 @@
           <a:chExt cx="0" cy="0"/>
         </a:xfrm>
       </p:grpSpPr>
+      <p:sp>
+        <p:nvSpPr>
+          <p:cNvPr id="2" name="Slide Number Placeholder 2"/>
+          <p:cNvSpPr>
+            <a:spLocks noGrp="1"/>
+          </p:cNvSpPr>
+          <p:nvPr>
+            <p:ph type="sldNum" sz="quarter" idx="4"/>
+          </p:nvPr>
+        </p:nvSpPr>
+        <p:spPr>
+          <a:xfrm>
+            <a:off x="11477880" y="6473952"/>
+            <a:ext cx="457200" cy="228600"/>
+          </a:xfrm>
+          <a:prstGeom prst="rect">
+            <a:avLst/>
+          </a:prstGeom>
+        </p:spPr>
+        <p:txBody>
+          <a:bodyPr vert="horz" lIns="0" tIns="0" rIns="0" bIns="0" rtlCol="0" anchor="ctr"/>
+          <a:lstStyle>
+            <a:lvl1pPr algn="r">
+              <a:defRPr sz="850">
+                <a:solidFill>
+                  <a:srgbClr val="6B7A82"/>
+                </a:solidFill>
+                <a:latin typeface="Calibri"/>
+              </a:defRPr>
+            </a:lvl1pPr>
+          </a:lstStyle>
+          <a:p>
+            <a:pPr algn="r"/>
+            <a:fld id="{832BFFA8-5D8A-4288-B069-7225ED41CEB7}" type="slidenum">
+              <a:rPr lang="en-US" sz="850" dirty="0">
+                <a:solidFill>
+                  <a:srgbClr val="6B7A82"/>
+                </a:solidFill>
+                <a:latin typeface="Calibri"/>
+              </a:rPr>
+              <a:t>‹#›</a:t>
+            </a:fld>
+            <a:endParaRPr lang="en-US" sz="850" dirty="0"/>
+          </a:p>
+        </p:txBody>
+      </p:sp>
     </p:spTree>
   </p:cSld>
   <p:clrMap bg1="lt1" tx1="dk1" bg2="lt2" tx2="dk2" accent1="accent1" accent2="accent2" accent3="accent3" accent4="accent4" accent5="accent5" accent6="accent6" hlink="hlink" folHlink="folHlink"/>
@@ -3408,6 +3500,43 @@
           </a:p>
         </p:txBody>
       </p:sp>
+      <p:sp>
+        <p:nvSpPr>
+          <p:cNvPr id="25" name="Slide Number Placeholder 25"/>
+          <p:cNvSpPr>
+            <a:spLocks noGrp="1"/>
+          </p:cNvSpPr>
+          <p:nvPr>
+            <p:ph type="sldNum" sz="quarter" idx="4"/>
+          </p:nvPr>
+        </p:nvSpPr>
+        <p:spPr>
+          <a:xfrm>
+            <a:off x="11477880" y="6473952"/>
+            <a:ext cx="457200" cy="228600"/>
+          </a:xfrm>
+          <a:prstGeom prst="rect">
+            <a:avLst/>
+          </a:prstGeom>
+        </p:spPr>
+        <p:txBody>
+          <a:bodyPr vert="horz" lIns="0" tIns="0" rIns="0" bIns="0" rtlCol="0" anchor="ctr"/>
+          <a:lstStyle/>
+          <a:p>
+            <a:pPr algn="r"/>
+            <a:fld id="{E2B9DDDE-79CF-4241-9624-E2211BEBF904}" type="slidenum">
+              <a:rPr lang="en-US" sz="850" dirty="0">
+                <a:solidFill>
+                  <a:srgbClr val="6B7A82"/>
+                </a:solidFill>
+                <a:latin typeface="Calibri"/>
+              </a:rPr>
+              <a:t>10</a:t>
+            </a:fld>
+            <a:endParaRPr lang="en-US" sz="850" dirty="0"/>
+          </a:p>
+        </p:txBody>
+      </p:sp>
     </p:spTree>
   </p:cSld>
   <p:clrMapOvr>
@@ -3865,6 +3994,43 @@
           </a:p>
         </p:txBody>
       </p:sp>
+      <p:sp>
+        <p:nvSpPr>
+          <p:cNvPr id="13" name="Slide Number Placeholder 13"/>
+          <p:cNvSpPr>
+            <a:spLocks noGrp="1"/>
+          </p:cNvSpPr>
+          <p:nvPr>
+            <p:ph type="sldNum" sz="quarter" idx="4"/>
+          </p:nvPr>
+        </p:nvSpPr>
+        <p:spPr>
+          <a:xfrm>
+            <a:off x="11477880" y="6473952"/>
+            <a:ext cx="457200" cy="228600"/>
+          </a:xfrm>
+          <a:prstGeom prst="rect">
+            <a:avLst/>
+          </a:prstGeom>
+        </p:spPr>
+        <p:txBody>
+          <a:bodyPr vert="horz" lIns="0" tIns="0" rIns="0" bIns="0" rtlCol="0" anchor="ctr"/>
+          <a:lstStyle/>
+          <a:p>
+            <a:pPr algn="r"/>
+            <a:fld id="{07BE9F51-F659-475D-A05E-196EAEBF0E08}" type="slidenum">
+              <a:rPr lang="en-US" sz="850" dirty="0">
+                <a:solidFill>
+                  <a:srgbClr val="6B7A82"/>
+                </a:solidFill>
+                <a:latin typeface="Calibri"/>
+              </a:rPr>
+              <a:t>11</a:t>
+            </a:fld>
+            <a:endParaRPr lang="en-US" sz="850" dirty="0"/>
+          </a:p>
+        </p:txBody>
+      </p:sp>
     </p:spTree>
   </p:cSld>
   <p:clrMapOvr>
@@ -4527,6 +4693,43 @@
           </a:p>
         </p:txBody>
       </p:sp>
+      <p:sp>
+        <p:nvSpPr>
+          <p:cNvPr id="16" name="Slide Number Placeholder 16"/>
+          <p:cNvSpPr>
+            <a:spLocks noGrp="1"/>
+          </p:cNvSpPr>
+          <p:nvPr>
+            <p:ph type="sldNum" sz="quarter" idx="4"/>
+          </p:nvPr>
+        </p:nvSpPr>
+        <p:spPr>
+          <a:xfrm>
+            <a:off x="11477880" y="6473952"/>
+            <a:ext cx="457200" cy="228600"/>
+          </a:xfrm>
+          <a:prstGeom prst="rect">
+            <a:avLst/>
+          </a:prstGeom>
+        </p:spPr>
+        <p:txBody>
+          <a:bodyPr vert="horz" lIns="0" tIns="0" rIns="0" bIns="0" rtlCol="0" anchor="ctr"/>
+          <a:lstStyle/>
+          <a:p>
+            <a:pPr algn="r"/>
+            <a:fld id="{9DFEBCD2-01C1-4724-BFCD-6F0870E15985}" type="slidenum">
+              <a:rPr lang="en-US" sz="850" dirty="0">
+                <a:solidFill>
+                  <a:srgbClr val="6B7A82"/>
+                </a:solidFill>
+                <a:latin typeface="Calibri"/>
+              </a:rPr>
+              <a:t>12</a:t>
+            </a:fld>
+            <a:endParaRPr lang="en-US" sz="850" dirty="0"/>
+          </a:p>
+        </p:txBody>
+      </p:sp>
     </p:spTree>
   </p:cSld>
   <p:clrMapOvr>
@@ -5413,6 +5616,43 @@
           </a:p>
         </p:txBody>
       </p:sp>
+      <p:sp>
+        <p:nvSpPr>
+          <p:cNvPr id="25" name="Slide Number Placeholder 25"/>
+          <p:cNvSpPr>
+            <a:spLocks noGrp="1"/>
+          </p:cNvSpPr>
+          <p:nvPr>
+            <p:ph type="sldNum" sz="quarter" idx="4"/>
+          </p:nvPr>
+        </p:nvSpPr>
+        <p:spPr>
+          <a:xfrm>
+            <a:off x="11477880" y="6473952"/>
+            <a:ext cx="457200" cy="228600"/>
+          </a:xfrm>
+          <a:prstGeom prst="rect">
+            <a:avLst/>
+          </a:prstGeom>
+        </p:spPr>
+        <p:txBody>
+          <a:bodyPr vert="horz" lIns="0" tIns="0" rIns="0" bIns="0" rtlCol="0" anchor="ctr"/>
+          <a:lstStyle/>
+          <a:p>
+            <a:pPr algn="r"/>
+            <a:fld id="{F829D80C-5120-4B1B-95F4-809401D7E479}" type="slidenum">
+              <a:rPr lang="en-US" sz="850" dirty="0">
+                <a:solidFill>
+                  <a:srgbClr val="6B7A82"/>
+                </a:solidFill>
+                <a:latin typeface="Calibri"/>
+              </a:rPr>
+              <a:t>13</a:t>
+            </a:fld>
+            <a:endParaRPr lang="en-US" sz="850" dirty="0"/>
+          </a:p>
+        </p:txBody>
+      </p:sp>
     </p:spTree>
   </p:cSld>
   <p:clrMapOvr>
@@ -6046,6 +6286,43 @@
           </a:p>
         </p:txBody>
       </p:sp>
+      <p:sp>
+        <p:nvSpPr>
+          <p:cNvPr id="19" name="Slide Number Placeholder 19"/>
+          <p:cNvSpPr>
+            <a:spLocks noGrp="1"/>
+          </p:cNvSpPr>
+          <p:nvPr>
+            <p:ph type="sldNum" sz="quarter" idx="4"/>
+          </p:nvPr>
+        </p:nvSpPr>
+        <p:spPr>
+          <a:xfrm>
+            <a:off x="11477880" y="6473952"/>
+            <a:ext cx="457200" cy="228600"/>
+          </a:xfrm>
+          <a:prstGeom prst="rect">
+            <a:avLst/>
+          </a:prstGeom>
+        </p:spPr>
+        <p:txBody>
+          <a:bodyPr vert="horz" lIns="0" tIns="0" rIns="0" bIns="0" rtlCol="0" anchor="ctr"/>
+          <a:lstStyle/>
+          <a:p>
+            <a:pPr algn="r"/>
+            <a:fld id="{25AAE0E2-DB59-414F-9852-A06193896751}" type="slidenum">
+              <a:rPr lang="en-US" sz="850" dirty="0">
+                <a:solidFill>
+                  <a:srgbClr val="6B7A82"/>
+                </a:solidFill>
+                <a:latin typeface="Calibri"/>
+              </a:rPr>
+              <a:t>14</a:t>
+            </a:fld>
+            <a:endParaRPr lang="en-US" sz="850" dirty="0"/>
+          </a:p>
+        </p:txBody>
+      </p:sp>
     </p:spTree>
   </p:cSld>
   <p:clrMapOvr>
@@ -6932,6 +7209,43 @@
           </a:p>
         </p:txBody>
       </p:sp>
+      <p:sp>
+        <p:nvSpPr>
+          <p:cNvPr id="25" name="Slide Number Placeholder 25"/>
+          <p:cNvSpPr>
+            <a:spLocks noGrp="1"/>
+          </p:cNvSpPr>
+          <p:nvPr>
+            <p:ph type="sldNum" sz="quarter" idx="4"/>
+          </p:nvPr>
+        </p:nvSpPr>
+        <p:spPr>
+          <a:xfrm>
+            <a:off x="11477880" y="6473952"/>
+            <a:ext cx="457200" cy="228600"/>
+          </a:xfrm>
+          <a:prstGeom prst="rect">
+            <a:avLst/>
+          </a:prstGeom>
+        </p:spPr>
+        <p:txBody>
+          <a:bodyPr vert="horz" lIns="0" tIns="0" rIns="0" bIns="0" rtlCol="0" anchor="ctr"/>
+          <a:lstStyle/>
+          <a:p>
+            <a:pPr algn="r"/>
+            <a:fld id="{3918EC9C-F6D4-40A6-B9F7-803C1782EAEA}" type="slidenum">
+              <a:rPr lang="en-US" sz="850" dirty="0">
+                <a:solidFill>
+                  <a:srgbClr val="6B7A82"/>
+                </a:solidFill>
+                <a:latin typeface="Calibri"/>
+              </a:rPr>
+              <a:t>15</a:t>
+            </a:fld>
+            <a:endParaRPr lang="en-US" sz="850" dirty="0"/>
+          </a:p>
+        </p:txBody>
+      </p:sp>
     </p:spTree>
   </p:cSld>
   <p:clrMapOvr>
@@ -8301,6 +8615,43 @@
               <a:t>Training the radio-astronomy interest group starts on this baseline — a roster of members is signed up.</a:t>
             </a:r>
             <a:endParaRPr lang="en-US" dirty="0"/>
+          </a:p>
+        </p:txBody>
+      </p:sp>
+      <p:sp>
+        <p:nvSpPr>
+          <p:cNvPr id="39" name="Slide Number Placeholder 39"/>
+          <p:cNvSpPr>
+            <a:spLocks noGrp="1"/>
+          </p:cNvSpPr>
+          <p:nvPr>
+            <p:ph type="sldNum" sz="quarter" idx="4"/>
+          </p:nvPr>
+        </p:nvSpPr>
+        <p:spPr>
+          <a:xfrm>
+            <a:off x="11477880" y="6473952"/>
+            <a:ext cx="457200" cy="228600"/>
+          </a:xfrm>
+          <a:prstGeom prst="rect">
+            <a:avLst/>
+          </a:prstGeom>
+        </p:spPr>
+        <p:txBody>
+          <a:bodyPr vert="horz" lIns="0" tIns="0" rIns="0" bIns="0" rtlCol="0" anchor="ctr"/>
+          <a:lstStyle/>
+          <a:p>
+            <a:pPr algn="r"/>
+            <a:fld id="{87F59D88-6D56-4DAF-97E6-F5488F2333B3}" type="slidenum">
+              <a:rPr lang="en-US" sz="850" dirty="0">
+                <a:solidFill>
+                  <a:srgbClr val="6B7A82"/>
+                </a:solidFill>
+                <a:latin typeface="Calibri"/>
+              </a:rPr>
+              <a:t>16</a:t>
+            </a:fld>
+            <a:endParaRPr lang="en-US" sz="850" dirty="0"/>
           </a:p>
         </p:txBody>
       </p:sp>
@@ -9689,6 +10040,43 @@
           </a:p>
         </p:txBody>
       </p:sp>
+      <p:sp>
+        <p:nvSpPr>
+          <p:cNvPr id="20" name="Slide Number Placeholder 20"/>
+          <p:cNvSpPr>
+            <a:spLocks noGrp="1"/>
+          </p:cNvSpPr>
+          <p:nvPr>
+            <p:ph type="sldNum" sz="quarter" idx="4"/>
+          </p:nvPr>
+        </p:nvSpPr>
+        <p:spPr>
+          <a:xfrm>
+            <a:off x="11477880" y="6473952"/>
+            <a:ext cx="457200" cy="228600"/>
+          </a:xfrm>
+          <a:prstGeom prst="rect">
+            <a:avLst/>
+          </a:prstGeom>
+        </p:spPr>
+        <p:txBody>
+          <a:bodyPr vert="horz" lIns="0" tIns="0" rIns="0" bIns="0" rtlCol="0" anchor="ctr"/>
+          <a:lstStyle/>
+          <a:p>
+            <a:pPr algn="r"/>
+            <a:fld id="{BD446756-E39E-4725-93FB-13FA05BADBB0}" type="slidenum">
+              <a:rPr lang="en-US" sz="850" dirty="0">
+                <a:solidFill>
+                  <a:srgbClr val="6B7A82"/>
+                </a:solidFill>
+                <a:latin typeface="Calibri"/>
+              </a:rPr>
+              <a:t>2</a:t>
+            </a:fld>
+            <a:endParaRPr lang="en-US" sz="850" dirty="0"/>
+          </a:p>
+        </p:txBody>
+      </p:sp>
     </p:spTree>
   </p:cSld>
   <p:clrMapOvr>
@@ -11301,6 +11689,43 @@
           </a:p>
         </p:txBody>
       </p:sp>
+      <p:sp>
+        <p:nvSpPr>
+          <p:cNvPr id="44" name="Slide Number Placeholder 44"/>
+          <p:cNvSpPr>
+            <a:spLocks noGrp="1"/>
+          </p:cNvSpPr>
+          <p:nvPr>
+            <p:ph type="sldNum" sz="quarter" idx="4"/>
+          </p:nvPr>
+        </p:nvSpPr>
+        <p:spPr>
+          <a:xfrm>
+            <a:off x="11477880" y="6473952"/>
+            <a:ext cx="457200" cy="228600"/>
+          </a:xfrm>
+          <a:prstGeom prst="rect">
+            <a:avLst/>
+          </a:prstGeom>
+        </p:spPr>
+        <p:txBody>
+          <a:bodyPr vert="horz" lIns="0" tIns="0" rIns="0" bIns="0" rtlCol="0" anchor="ctr"/>
+          <a:lstStyle/>
+          <a:p>
+            <a:pPr algn="r"/>
+            <a:fld id="{5D902D0F-5B8C-4D3A-A24A-FF2B7FD4C56C}" type="slidenum">
+              <a:rPr lang="en-US" sz="850" dirty="0">
+                <a:solidFill>
+                  <a:srgbClr val="6B7A82"/>
+                </a:solidFill>
+                <a:latin typeface="Calibri"/>
+              </a:rPr>
+              <a:t>3</a:t>
+            </a:fld>
+            <a:endParaRPr lang="en-US" sz="850" dirty="0"/>
+          </a:p>
+        </p:txBody>
+      </p:sp>
     </p:spTree>
   </p:cSld>
   <p:clrMapOvr>
@@ -12194,6 +12619,43 @@
           </a:p>
         </p:txBody>
       </p:sp>
+      <p:sp>
+        <p:nvSpPr>
+          <p:cNvPr id="26" name="Slide Number Placeholder 26"/>
+          <p:cNvSpPr>
+            <a:spLocks noGrp="1"/>
+          </p:cNvSpPr>
+          <p:nvPr>
+            <p:ph type="sldNum" sz="quarter" idx="4"/>
+          </p:nvPr>
+        </p:nvSpPr>
+        <p:spPr>
+          <a:xfrm>
+            <a:off x="11477880" y="6473952"/>
+            <a:ext cx="457200" cy="228600"/>
+          </a:xfrm>
+          <a:prstGeom prst="rect">
+            <a:avLst/>
+          </a:prstGeom>
+        </p:spPr>
+        <p:txBody>
+          <a:bodyPr vert="horz" lIns="0" tIns="0" rIns="0" bIns="0" rtlCol="0" anchor="ctr"/>
+          <a:lstStyle/>
+          <a:p>
+            <a:pPr algn="r"/>
+            <a:fld id="{28FBE091-B4BE-475C-8E05-00078E6FE657}" type="slidenum">
+              <a:rPr lang="en-US" sz="850" dirty="0">
+                <a:solidFill>
+                  <a:srgbClr val="6B7A82"/>
+                </a:solidFill>
+                <a:latin typeface="Calibri"/>
+              </a:rPr>
+              <a:t>4</a:t>
+            </a:fld>
+            <a:endParaRPr lang="en-US" sz="850" dirty="0"/>
+          </a:p>
+        </p:txBody>
+      </p:sp>
     </p:spTree>
   </p:cSld>
   <p:clrMapOvr>
@@ -12419,6 +12881,43 @@
           </a:prstGeom>
         </p:spPr>
       </p:pic>
+      <p:sp>
+        <p:nvSpPr>
+          <p:cNvPr id="9" name="Slide Number Placeholder 9"/>
+          <p:cNvSpPr>
+            <a:spLocks noGrp="1"/>
+          </p:cNvSpPr>
+          <p:nvPr>
+            <p:ph type="sldNum" sz="quarter" idx="4"/>
+          </p:nvPr>
+        </p:nvSpPr>
+        <p:spPr>
+          <a:xfrm>
+            <a:off x="11477880" y="6473952"/>
+            <a:ext cx="457200" cy="228600"/>
+          </a:xfrm>
+          <a:prstGeom prst="rect">
+            <a:avLst/>
+          </a:prstGeom>
+        </p:spPr>
+        <p:txBody>
+          <a:bodyPr vert="horz" lIns="0" tIns="0" rIns="0" bIns="0" rtlCol="0" anchor="ctr"/>
+          <a:lstStyle/>
+          <a:p>
+            <a:pPr algn="r"/>
+            <a:fld id="{0EE33691-5852-40E0-8221-5FA2C0BA7807}" type="slidenum">
+              <a:rPr lang="en-US" sz="850" dirty="0">
+                <a:solidFill>
+                  <a:srgbClr val="6B7A82"/>
+                </a:solidFill>
+                <a:latin typeface="Calibri"/>
+              </a:rPr>
+              <a:t>5</a:t>
+            </a:fld>
+            <a:endParaRPr lang="en-US" sz="850" dirty="0"/>
+          </a:p>
+        </p:txBody>
+      </p:sp>
     </p:spTree>
     <p:extLst>
       <p:ext uri="{BB962C8B-B14F-4D97-AF65-F5344CB8AC3E}">
@@ -13383,6 +13882,43 @@
           </a:prstGeom>
         </p:spPr>
       </p:pic>
+      <p:sp>
+        <p:nvSpPr>
+          <p:cNvPr id="25" name="Slide Number Placeholder 25"/>
+          <p:cNvSpPr>
+            <a:spLocks noGrp="1"/>
+          </p:cNvSpPr>
+          <p:nvPr>
+            <p:ph type="sldNum" sz="quarter" idx="4"/>
+          </p:nvPr>
+        </p:nvSpPr>
+        <p:spPr>
+          <a:xfrm>
+            <a:off x="11477880" y="6473952"/>
+            <a:ext cx="457200" cy="228600"/>
+          </a:xfrm>
+          <a:prstGeom prst="rect">
+            <a:avLst/>
+          </a:prstGeom>
+        </p:spPr>
+        <p:txBody>
+          <a:bodyPr vert="horz" lIns="0" tIns="0" rIns="0" bIns="0" rtlCol="0" anchor="ctr"/>
+          <a:lstStyle/>
+          <a:p>
+            <a:pPr algn="r"/>
+            <a:fld id="{8E22918F-97EC-4791-BD0B-F90039D36CC5}" type="slidenum">
+              <a:rPr lang="en-US" sz="850" dirty="0">
+                <a:solidFill>
+                  <a:srgbClr val="6B7A82"/>
+                </a:solidFill>
+                <a:latin typeface="Calibri"/>
+              </a:rPr>
+              <a:t>6</a:t>
+            </a:fld>
+            <a:endParaRPr lang="en-US" sz="850" dirty="0"/>
+          </a:p>
+        </p:txBody>
+      </p:sp>
     </p:spTree>
   </p:cSld>
   <p:clrMapOvr>
@@ -14445,6 +14981,43 @@
               <a:t>one laptop — planning, RF checks, recording</a:t>
             </a:r>
             <a:endParaRPr lang="en-US" sz="1150" dirty="0"/>
+          </a:p>
+        </p:txBody>
+      </p:sp>
+      <p:sp>
+        <p:nvSpPr>
+          <p:cNvPr id="30" name="Slide Number Placeholder 30"/>
+          <p:cNvSpPr>
+            <a:spLocks noGrp="1"/>
+          </p:cNvSpPr>
+          <p:nvPr>
+            <p:ph type="sldNum" sz="quarter" idx="4"/>
+          </p:nvPr>
+        </p:nvSpPr>
+        <p:spPr>
+          <a:xfrm>
+            <a:off x="11477880" y="6473952"/>
+            <a:ext cx="457200" cy="228600"/>
+          </a:xfrm>
+          <a:prstGeom prst="rect">
+            <a:avLst/>
+          </a:prstGeom>
+        </p:spPr>
+        <p:txBody>
+          <a:bodyPr vert="horz" lIns="0" tIns="0" rIns="0" bIns="0" rtlCol="0" anchor="ctr"/>
+          <a:lstStyle/>
+          <a:p>
+            <a:pPr algn="r"/>
+            <a:fld id="{A1078162-12D1-486C-B275-7DA9A06905FA}" type="slidenum">
+              <a:rPr lang="en-US" sz="850" dirty="0">
+                <a:solidFill>
+                  <a:srgbClr val="6B7A82"/>
+                </a:solidFill>
+                <a:latin typeface="Calibri"/>
+              </a:rPr>
+              <a:t>7</a:t>
+            </a:fld>
+            <a:endParaRPr lang="en-US" sz="850" dirty="0"/>
           </a:p>
         </p:txBody>
       </p:sp>
@@ -16213,6 +16786,43 @@
           </a:p>
         </p:txBody>
       </p:sp>
+      <p:sp>
+        <p:nvSpPr>
+          <p:cNvPr id="21" name="Slide Number Placeholder 21"/>
+          <p:cNvSpPr>
+            <a:spLocks noGrp="1"/>
+          </p:cNvSpPr>
+          <p:nvPr>
+            <p:ph type="sldNum" sz="quarter" idx="4"/>
+          </p:nvPr>
+        </p:nvSpPr>
+        <p:spPr>
+          <a:xfrm>
+            <a:off x="11477880" y="6473952"/>
+            <a:ext cx="457200" cy="228600"/>
+          </a:xfrm>
+          <a:prstGeom prst="rect">
+            <a:avLst/>
+          </a:prstGeom>
+        </p:spPr>
+        <p:txBody>
+          <a:bodyPr vert="horz" lIns="0" tIns="0" rIns="0" bIns="0" rtlCol="0" anchor="ctr"/>
+          <a:lstStyle/>
+          <a:p>
+            <a:pPr algn="r"/>
+            <a:fld id="{C8F48EB4-ED29-4720-B413-AD296126C228}" type="slidenum">
+              <a:rPr lang="en-US" sz="850" dirty="0">
+                <a:solidFill>
+                  <a:srgbClr val="6B7A82"/>
+                </a:solidFill>
+                <a:latin typeface="Calibri"/>
+              </a:rPr>
+              <a:t>8</a:t>
+            </a:fld>
+            <a:endParaRPr lang="en-US" sz="850" dirty="0"/>
+          </a:p>
+        </p:txBody>
+      </p:sp>
     </p:spTree>
   </p:cSld>
   <p:clrMapOvr>
@@ -16646,6 +17256,43 @@
               <a:t>In the field it stood at ~20 σ; RFI cleanup and one timebase repair recovered the rest — that story is the next slide</a:t>
             </a:r>
             <a:endParaRPr lang="en-US" sz="2000" dirty="0"/>
+          </a:p>
+        </p:txBody>
+      </p:sp>
+      <p:sp>
+        <p:nvSpPr>
+          <p:cNvPr id="13" name="Slide Number Placeholder 13"/>
+          <p:cNvSpPr>
+            <a:spLocks noGrp="1"/>
+          </p:cNvSpPr>
+          <p:nvPr>
+            <p:ph type="sldNum" sz="quarter" idx="4"/>
+          </p:nvPr>
+        </p:nvSpPr>
+        <p:spPr>
+          <a:xfrm>
+            <a:off x="11477880" y="6473952"/>
+            <a:ext cx="457200" cy="228600"/>
+          </a:xfrm>
+          <a:prstGeom prst="rect">
+            <a:avLst/>
+          </a:prstGeom>
+        </p:spPr>
+        <p:txBody>
+          <a:bodyPr vert="horz" lIns="0" tIns="0" rIns="0" bIns="0" rtlCol="0" anchor="ctr"/>
+          <a:lstStyle/>
+          <a:p>
+            <a:pPr algn="r"/>
+            <a:fld id="{251994EA-03D3-4FD5-8B48-B20D63795AC1}" type="slidenum">
+              <a:rPr lang="en-US" sz="850" dirty="0">
+                <a:solidFill>
+                  <a:srgbClr val="6B7A82"/>
+                </a:solidFill>
+                <a:latin typeface="Calibri"/>
+              </a:rPr>
+              <a:t>9</a:t>
+            </a:fld>
+            <a:endParaRPr lang="en-US" sz="850" dirty="0"/>
           </a:p>
         </p:txBody>
       </p:sp>

</xml_diff>

<commit_message>
SARA deck: Rick's second manual revision pass
</commit_message>
<xml_diff>
--- a/reports/sara-2026/Lowering_the_Barrier_to_Radio_Astronomy_SARA_2026.pptx
+++ b/reports/sara-2026/Lowering_the_Barrier_to_Radio_Astronomy_SARA_2026.pptx
@@ -8173,8 +8173,8 @@
         </p:nvSpPr>
         <p:spPr>
           <a:xfrm>
-            <a:off x="749808" y="5394960"/>
-            <a:ext cx="3520440" cy="612648"/>
+            <a:off x="688427" y="5394960"/>
+            <a:ext cx="3636579" cy="531876"/>
           </a:xfrm>
           <a:prstGeom prst="rect">
             <a:avLst/>
@@ -12726,7 +12726,7 @@
                 <a:ea typeface="Calibri" pitchFamily="34" charset="-122"/>
                 <a:cs typeface="Calibri" pitchFamily="34" charset="-120"/>
               </a:rPr>
-              <a:t>THE ANSWER</a:t>
+              <a:t>THE INSTRUMENT, LIVE</a:t>
             </a:r>
             <a:endParaRPr lang="en-US" sz="1100" dirty="0"/>
           </a:p>
@@ -12873,8 +12873,8 @@
         </p:blipFill>
         <p:spPr>
           <a:xfrm>
-            <a:off x="1295400" y="1200404"/>
-            <a:ext cx="9602251" cy="5221224"/>
+            <a:off x="1628184" y="1615202"/>
+            <a:ext cx="8935632" cy="4858750"/>
           </a:xfrm>
           <a:prstGeom prst="rect">
             <a:avLst/>
@@ -12915,6 +12915,50 @@
               <a:t>5</a:t>
             </a:fld>
             <a:endParaRPr lang="en-US" sz="850" dirty="0"/>
+          </a:p>
+        </p:txBody>
+      </p:sp>
+      <p:sp>
+        <p:nvSpPr>
+          <p:cNvPr id="6" name="Text 4">
+            <a:extLst>
+              <a:ext uri="{FF2B5EF4-FFF2-40B4-BE49-F238E27FC236}">
+                <a16:creationId xmlns:a16="http://schemas.microsoft.com/office/drawing/2014/main" id="{0D3B02C3-889A-6651-BFB4-46C9255456CB}"/>
+              </a:ext>
+            </a:extLst>
+          </p:cNvPr>
+          <p:cNvSpPr/>
+          <p:nvPr/>
+        </p:nvSpPr>
+        <p:spPr>
+          <a:xfrm>
+            <a:off x="566928" y="1261872"/>
+            <a:ext cx="7772400" cy="365760"/>
+          </a:xfrm>
+          <a:prstGeom prst="rect">
+            <a:avLst/>
+          </a:prstGeom>
+          <a:noFill/>
+          <a:ln/>
+        </p:spPr>
+        <p:txBody>
+          <a:bodyPr wrap="square" lIns="0" tIns="0" rIns="0" bIns="0" rtlCol="0" anchor="ctr"/>
+          <a:lstStyle/>
+          <a:p>
+            <a:pPr marL="0" indent="0">
+              <a:buNone/>
+            </a:pPr>
+            <a:r>
+              <a:rPr lang="en-US" sz="1600" b="0" i="0" dirty="0">
+                <a:solidFill>
+                  <a:srgbClr val="0A0A0A"/>
+                </a:solidFill>
+                <a:effectLst/>
+                <a:latin typeface="Anthropic Sans"/>
+              </a:rPr>
+              <a:t>Live B210 at 1420 MHz: three weak test signals above a sub-dB noise floor</a:t>
+            </a:r>
+            <a:endParaRPr lang="en-US" sz="1600" dirty="0"/>
           </a:p>
         </p:txBody>
       </p:sp>

</xml_diff>